<commit_message>
Update presentation for Research Lens AI Sprint 3 with new insights and data
</commit_message>
<xml_diff>
--- a/presentations/ResearchLens_AI_Sprint3_Update.pptx
+++ b/presentations/ResearchLens_AI_Sprint3_Update.pptx
@@ -769,7 +769,7 @@
           <a:p>
             <a:r>
               <a:rPr lang="en-US" dirty="0"/>
-              <a:t>Key achievements: the structured 300-500 word summary format, two independent AI analyses per paper, the new AI Paper Analysis hub, the multi-note system, and the automatic legacy-notes migration. This closes out all four Sprint 3 roadmap items; Sprint 4 (agentic RAG) is out of scope for this deck.</a:t>
+              <a:t>A forward look at Sprint 4 (Research Intelligence - Agentic RAG), mapped 1:1 to its four roadmap line items: evidence tracking, Ask Your Literature, structured paper comparison, and a minimal tool-using OpenAI Agent - the project's core agentic AI deliverable. Paper comparison is flagged 'Started Early' since the Literature Matrix (AI-extracted Methodology/Sample/Findings/Limitations across a project's saved papers, directly editable) is already built ahead of its Sprint 4 slot, the same way PDF upload shipped early in Sprint 2.</a:t>
             </a:r>
             <a:endParaRPr lang="en-US" dirty="0"/>
           </a:p>
@@ -3316,7 +3316,7 @@
                 <a:ea typeface="Cambria" pitchFamily="34" charset="-122"/>
                 <a:cs typeface="Cambria" pitchFamily="34" charset="-120"/>
               </a:rPr>
-              <a:t>Sprint 3 Key Achievements</a:t>
+              <a:t>Coming in Sprint 4</a:t>
             </a:r>
             <a:endParaRPr lang="en-US" sz="3000" dirty="0"/>
           </a:p>
@@ -3355,7 +3355,7 @@
                 <a:ea typeface="Calibri" pitchFamily="34" charset="-122"/>
                 <a:cs typeface="Calibri" pitchFamily="34" charset="-120"/>
               </a:rPr>
-              <a:t>Measurable progress since the Sprint 2 prototype review - Sprint 3 scope, complete.</a:t>
+              <a:t>Per the project roadmap's Sprint 4 scope - Research Intelligence: Agentic RAG, scoped only to the literature you've chosen to save, never the open web.</a:t>
             </a:r>
             <a:endParaRPr lang="en-US" sz="1350" dirty="0"/>
           </a:p>
@@ -3369,340 +3369,55 @@
         </p:nvSpPr>
         <p:spPr>
           <a:xfrm>
-            <a:off x="502920" y="1645920"/>
-            <a:ext cx="3484778" cy="1417320"/>
+            <a:off x="502920" y="1600200"/>
+            <a:ext cx="5410048" cy="2057400"/>
           </a:xfrm>
           <a:prstGeom prst="roundRect">
             <a:avLst>
-              <a:gd name="adj" fmla="val 5161"/>
+              <a:gd name="adj" fmla="val 4000"/>
             </a:avLst>
           </a:prstGeom>
           <a:solidFill>
-            <a:srgbClr val="EEEAFD"/>
-          </a:solidFill>
-          <a:ln/>
-        </p:spPr>
-      </p:sp>
-      <p:sp>
-        <p:nvSpPr>
-          <p:cNvPr id="5" name="Text 3"/>
-          <p:cNvSpPr txBox="1"/>
-          <p:nvPr/>
-        </p:nvSpPr>
-        <p:spPr>
-          <a:xfrm>
-            <a:off x="502920" y="1783080"/>
-            <a:ext cx="3484778" cy="685800"/>
-          </a:xfrm>
-          <a:prstGeom prst="rect">
-            <a:avLst/>
-          </a:prstGeom>
-          <a:noFill/>
-          <a:ln/>
-        </p:spPr>
-        <p:txBody>
-          <a:bodyPr wrap="square" lIns="0" tIns="0" rIns="0" bIns="0" rtlCol="0" anchor="ctr"/>
-          <a:lstStyle/>
-          <a:p>
-            <a:pPr algn="ctr" indent="0" marL="0">
-              <a:buNone/>
-            </a:pPr>
-            <a:r>
-              <a:rPr lang="en-US" sz="3400" b="1" dirty="0">
-                <a:solidFill>
-                  <a:srgbClr val="6D5EF0"/>
-                </a:solidFill>
-                <a:latin typeface="Cambria" pitchFamily="34" charset="0"/>
-                <a:ea typeface="Cambria" pitchFamily="34" charset="-122"/>
-                <a:cs typeface="Cambria" pitchFamily="34" charset="-120"/>
-              </a:rPr>
-              <a:t>300-500</a:t>
-            </a:r>
-            <a:endParaRPr lang="en-US" sz="3400" dirty="0"/>
-          </a:p>
-        </p:txBody>
-      </p:sp>
-      <p:sp>
-        <p:nvSpPr>
-          <p:cNvPr id="6" name="Text 4"/>
-          <p:cNvSpPr txBox="1"/>
-          <p:nvPr/>
-        </p:nvSpPr>
-        <p:spPr>
-          <a:xfrm>
-            <a:off x="731520" y="2487168"/>
-            <a:ext cx="3027578" cy="502920"/>
-          </a:xfrm>
-          <a:prstGeom prst="rect">
-            <a:avLst/>
-          </a:prstGeom>
-          <a:noFill/>
-          <a:ln/>
-        </p:spPr>
-        <p:txBody>
-          <a:bodyPr wrap="square" lIns="0" tIns="0" rIns="0" bIns="0" rtlCol="0" anchor="ctr"/>
-          <a:lstStyle/>
-          <a:p>
-            <a:pPr algn="ctr" indent="0" marL="0">
-              <a:buNone/>
-            </a:pPr>
-            <a:r>
-              <a:rPr lang="en-US" sz="1100" dirty="0">
-                <a:solidFill>
-                  <a:srgbClr val="1E2A3A"/>
-                </a:solidFill>
-                <a:latin typeface="Calibri" pitchFamily="34" charset="0"/>
-                <a:ea typeface="Calibri" pitchFamily="34" charset="-122"/>
-                <a:cs typeface="Calibri" pitchFamily="34" charset="-120"/>
-              </a:rPr>
-              <a:t>Words per structured AI-generated summary</a:t>
-            </a:r>
-            <a:endParaRPr lang="en-US" sz="1100" dirty="0"/>
-          </a:p>
-        </p:txBody>
-      </p:sp>
-      <p:sp>
-        <p:nvSpPr>
-          <p:cNvPr id="7" name="Shape 5"/>
+            <a:srgbClr val="FFFFFF"/>
+          </a:solidFill>
+          <a:ln w="12700">
+            <a:solidFill>
+              <a:srgbClr val="E5E7EB"/>
+            </a:solidFill>
+            <a:prstDash val="solid"/>
+          </a:ln>
+          <a:effectLst>
+            <a:outerShdw sx="100000" sy="100000" kx="0" ky="0" algn="bl" rotWithShape="0" blurRad="101600" dist="38100" dir="5400000">
+              <a:srgbClr val="1E2A3A">
+                <a:alpha val="12000"/>
+              </a:srgbClr>
+            </a:outerShdw>
+          </a:effectLst>
+        </p:spPr>
+      </p:sp>
+      <p:sp>
+        <p:nvSpPr>
+          <p:cNvPr id="5" name="Shape 3"/>
           <p:cNvSpPr/>
           <p:nvPr/>
         </p:nvSpPr>
         <p:spPr>
           <a:xfrm>
-            <a:off x="4353458" y="1645920"/>
-            <a:ext cx="3484778" cy="1417320"/>
-          </a:xfrm>
-          <a:prstGeom prst="roundRect">
-            <a:avLst>
-              <a:gd name="adj" fmla="val 5161"/>
-            </a:avLst>
-          </a:prstGeom>
-          <a:solidFill>
-            <a:srgbClr val="ECFDF5"/>
-          </a:solidFill>
-          <a:ln/>
-        </p:spPr>
-      </p:sp>
-      <p:sp>
-        <p:nvSpPr>
-          <p:cNvPr id="8" name="Text 6"/>
-          <p:cNvSpPr txBox="1"/>
-          <p:nvPr/>
-        </p:nvSpPr>
-        <p:spPr>
-          <a:xfrm>
-            <a:off x="4353458" y="1783080"/>
-            <a:ext cx="3484778" cy="685800"/>
-          </a:xfrm>
-          <a:prstGeom prst="rect">
-            <a:avLst/>
-          </a:prstGeom>
-          <a:noFill/>
-          <a:ln/>
-        </p:spPr>
-        <p:txBody>
-          <a:bodyPr wrap="square" lIns="0" tIns="0" rIns="0" bIns="0" rtlCol="0" anchor="ctr"/>
-          <a:lstStyle/>
-          <a:p>
-            <a:pPr algn="ctr" indent="0" marL="0">
-              <a:buNone/>
-            </a:pPr>
-            <a:r>
-              <a:rPr lang="en-US" sz="3400" b="1" dirty="0">
-                <a:solidFill>
-                  <a:srgbClr val="0F8B7E"/>
-                </a:solidFill>
-                <a:latin typeface="Cambria" pitchFamily="34" charset="0"/>
-                <a:ea typeface="Cambria" pitchFamily="34" charset="-122"/>
-                <a:cs typeface="Cambria" pitchFamily="34" charset="-120"/>
-              </a:rPr>
-              <a:t>2</a:t>
-            </a:r>
-            <a:endParaRPr lang="en-US" sz="3400" dirty="0"/>
-          </a:p>
-        </p:txBody>
-      </p:sp>
-      <p:sp>
-        <p:nvSpPr>
-          <p:cNvPr id="9" name="Text 7"/>
-          <p:cNvSpPr txBox="1"/>
-          <p:nvPr/>
-        </p:nvSpPr>
-        <p:spPr>
-          <a:xfrm>
-            <a:off x="4582058" y="2487168"/>
-            <a:ext cx="3027578" cy="502920"/>
-          </a:xfrm>
-          <a:prstGeom prst="rect">
-            <a:avLst/>
-          </a:prstGeom>
-          <a:noFill/>
-          <a:ln/>
-        </p:spPr>
-        <p:txBody>
-          <a:bodyPr wrap="square" lIns="0" tIns="0" rIns="0" bIns="0" rtlCol="0" anchor="ctr"/>
-          <a:lstStyle/>
-          <a:p>
-            <a:pPr algn="ctr" indent="0" marL="0">
-              <a:buNone/>
-            </a:pPr>
-            <a:r>
-              <a:rPr lang="en-US" sz="1100" dirty="0">
-                <a:solidFill>
-                  <a:srgbClr val="1E2A3A"/>
-                </a:solidFill>
-                <a:latin typeface="Calibri" pitchFamily="34" charset="0"/>
-                <a:ea typeface="Calibri" pitchFamily="34" charset="-122"/>
-                <a:cs typeface="Calibri" pitchFamily="34" charset="-120"/>
-              </a:rPr>
-              <a:t>Independent AI analyses per saved paper</a:t>
-            </a:r>
-            <a:endParaRPr lang="en-US" sz="1100" dirty="0"/>
-          </a:p>
-        </p:txBody>
-      </p:sp>
-      <p:sp>
-        <p:nvSpPr>
-          <p:cNvPr id="10" name="Shape 8"/>
-          <p:cNvSpPr/>
-          <p:nvPr/>
-        </p:nvSpPr>
-        <p:spPr>
-          <a:xfrm>
-            <a:off x="8203997" y="1645920"/>
-            <a:ext cx="3484778" cy="1417320"/>
-          </a:xfrm>
-          <a:prstGeom prst="roundRect">
-            <a:avLst>
-              <a:gd name="adj" fmla="val 5161"/>
-            </a:avLst>
-          </a:prstGeom>
-          <a:solidFill>
-            <a:srgbClr val="FEF3E2"/>
-          </a:solidFill>
-          <a:ln/>
-        </p:spPr>
-      </p:sp>
-      <p:sp>
-        <p:nvSpPr>
-          <p:cNvPr id="11" name="Text 9"/>
-          <p:cNvSpPr txBox="1"/>
-          <p:nvPr/>
-        </p:nvSpPr>
-        <p:spPr>
-          <a:xfrm>
-            <a:off x="8203997" y="1783080"/>
-            <a:ext cx="3484778" cy="685800"/>
-          </a:xfrm>
-          <a:prstGeom prst="rect">
-            <a:avLst/>
-          </a:prstGeom>
-          <a:noFill/>
-          <a:ln/>
-        </p:spPr>
-        <p:txBody>
-          <a:bodyPr wrap="square" lIns="0" tIns="0" rIns="0" bIns="0" rtlCol="0" anchor="ctr"/>
-          <a:lstStyle/>
-          <a:p>
-            <a:pPr algn="ctr" indent="0" marL="0">
-              <a:buNone/>
-            </a:pPr>
-            <a:r>
-              <a:rPr lang="en-US" sz="3400" b="1" dirty="0">
-                <a:solidFill>
-                  <a:srgbClr val="C77D14"/>
-                </a:solidFill>
-                <a:latin typeface="Cambria" pitchFamily="34" charset="0"/>
-                <a:ea typeface="Cambria" pitchFamily="34" charset="-122"/>
-                <a:cs typeface="Cambria" pitchFamily="34" charset="-120"/>
-              </a:rPr>
-              <a:t>100%</a:t>
-            </a:r>
-            <a:endParaRPr lang="en-US" sz="3400" dirty="0"/>
-          </a:p>
-        </p:txBody>
-      </p:sp>
-      <p:sp>
-        <p:nvSpPr>
-          <p:cNvPr id="12" name="Text 10"/>
-          <p:cNvSpPr txBox="1"/>
-          <p:nvPr/>
-        </p:nvSpPr>
-        <p:spPr>
-          <a:xfrm>
-            <a:off x="8432597" y="2487168"/>
-            <a:ext cx="3027578" cy="502920"/>
-          </a:xfrm>
-          <a:prstGeom prst="rect">
-            <a:avLst/>
-          </a:prstGeom>
-          <a:noFill/>
-          <a:ln/>
-        </p:spPr>
-        <p:txBody>
-          <a:bodyPr wrap="square" lIns="0" tIns="0" rIns="0" bIns="0" rtlCol="0" anchor="ctr"/>
-          <a:lstStyle/>
-          <a:p>
-            <a:pPr algn="ctr" indent="0" marL="0">
-              <a:buNone/>
-            </a:pPr>
-            <a:r>
-              <a:rPr lang="en-US" sz="1100" dirty="0">
-                <a:solidFill>
-                  <a:srgbClr val="1E2A3A"/>
-                </a:solidFill>
-                <a:latin typeface="Calibri" pitchFamily="34" charset="0"/>
-                <a:ea typeface="Calibri" pitchFamily="34" charset="-122"/>
-                <a:cs typeface="Calibri" pitchFamily="34" charset="-120"/>
-              </a:rPr>
-              <a:t>Of existing note data auto-migrated, zero loss</a:t>
-            </a:r>
-            <a:endParaRPr lang="en-US" sz="1100" dirty="0"/>
-          </a:p>
-        </p:txBody>
-      </p:sp>
-      <p:sp>
-        <p:nvSpPr>
-          <p:cNvPr id="13" name="Text 11"/>
-          <p:cNvSpPr txBox="1"/>
-          <p:nvPr/>
-        </p:nvSpPr>
-        <p:spPr>
-          <a:xfrm>
-            <a:off x="502920" y="3337560"/>
-            <a:ext cx="5486400" cy="320040"/>
-          </a:xfrm>
-          <a:prstGeom prst="rect">
-            <a:avLst/>
-          </a:prstGeom>
-          <a:noFill/>
-          <a:ln/>
-        </p:spPr>
-        <p:txBody>
-          <a:bodyPr wrap="square" lIns="0" tIns="0" rIns="0" bIns="0" rtlCol="0" anchor="ctr"/>
-          <a:lstStyle/>
-          <a:p>
-            <a:pPr indent="0" marL="0">
-              <a:buNone/>
-            </a:pPr>
-            <a:r>
-              <a:rPr lang="en-US" sz="1500" b="1" dirty="0">
-                <a:solidFill>
-                  <a:srgbClr val="0F172A"/>
-                </a:solidFill>
-                <a:latin typeface="Cambria" pitchFamily="34" charset="0"/>
-                <a:ea typeface="Cambria" pitchFamily="34" charset="-122"/>
-                <a:cs typeface="Cambria" pitchFamily="34" charset="-120"/>
-              </a:rPr>
-              <a:t>What shipped</a:t>
-            </a:r>
-            <a:endParaRPr lang="en-US" sz="1500" dirty="0"/>
-          </a:p>
-        </p:txBody>
+            <a:off x="795528" y="1892808"/>
+            <a:ext cx="566928" cy="566928"/>
+          </a:xfrm>
+          <a:prstGeom prst="ellipse">
+            <a:avLst/>
+          </a:prstGeom>
+          <a:solidFill>
+            <a:srgbClr val="EFF6FF"/>
+          </a:solidFill>
+          <a:ln/>
+        </p:spPr>
       </p:sp>
       <p:pic>
         <p:nvPicPr>
-          <p:cNvPr id="14" name="Image 0" descr="/tmp/claude-0/-home-claude/8aa44312-0fe2-5592-9e58-f7573fdf65a9/scratchpad/pptx_work/icons/check-green.png">    </p:cNvPr>
+          <p:cNvPr id="6" name="Image 0" descr="/tmp/claude-0/-home-claude/8aa44312-0fe2-5592-9e58-f7573fdf65a9/scratchpad/pptx_work/icons/link.png">    </p:cNvPr>
           <p:cNvPicPr>
             <a:picLocks noChangeAspect="1"/>
           </p:cNvPicPr>
@@ -3716,8 +3431,8 @@
         </p:blipFill>
         <p:spPr>
           <a:xfrm>
-            <a:off x="502920" y="3794760"/>
-            <a:ext cx="201168" cy="201168"/>
+            <a:off x="942929" y="2040209"/>
+            <a:ext cx="272125" cy="272125"/>
           </a:xfrm>
           <a:prstGeom prst="rect">
             <a:avLst/>
@@ -3726,49 +3441,142 @@
       </p:pic>
       <p:sp>
         <p:nvSpPr>
-          <p:cNvPr id="15" name="Text 12"/>
-          <p:cNvSpPr txBox="1"/>
-          <p:nvPr/>
-        </p:nvSpPr>
-        <p:spPr>
-          <a:xfrm>
-            <a:off x="813816" y="3712464"/>
-            <a:ext cx="5122012" cy="502920"/>
-          </a:xfrm>
-          <a:prstGeom prst="rect">
-            <a:avLst/>
-          </a:prstGeom>
-          <a:noFill/>
-          <a:ln/>
-        </p:spPr>
-        <p:txBody>
-          <a:bodyPr wrap="square" lIns="0" tIns="0" rIns="0" bIns="0" rtlCol="0" anchor="t"/>
+          <p:cNvPr id="7" name="Text 4"/>
+          <p:cNvSpPr txBox="1"/>
+          <p:nvPr/>
+        </p:nvSpPr>
+        <p:spPr>
+          <a:xfrm>
+            <a:off x="1554480" y="1892808"/>
+            <a:ext cx="4084168" cy="365760"/>
+          </a:xfrm>
+          <a:prstGeom prst="rect">
+            <a:avLst/>
+          </a:prstGeom>
+          <a:noFill/>
+          <a:ln/>
+        </p:spPr>
+        <p:txBody>
+          <a:bodyPr wrap="square" lIns="0" tIns="0" rIns="0" bIns="0" rtlCol="0" anchor="ctr"/>
+          <a:lstStyle/>
+          <a:p>
+            <a:pPr indent="0" marL="0">
+              <a:buNone/>
+            </a:pPr>
+            <a:r>
+              <a:rPr lang="en-US" sz="1650" b="1" dirty="0">
+                <a:solidFill>
+                  <a:srgbClr val="0F172A"/>
+                </a:solidFill>
+                <a:latin typeface="Cambria" pitchFamily="34" charset="0"/>
+                <a:ea typeface="Cambria" pitchFamily="34" charset="-122"/>
+                <a:cs typeface="Cambria" pitchFamily="34" charset="-120"/>
+              </a:rPr>
+              <a:t>Evidence Tracking</a:t>
+            </a:r>
+            <a:endParaRPr lang="en-US" sz="1650" dirty="0"/>
+          </a:p>
+        </p:txBody>
+      </p:sp>
+      <p:sp>
+        <p:nvSpPr>
+          <p:cNvPr id="8" name="Text 5"/>
+          <p:cNvSpPr txBox="1"/>
+          <p:nvPr/>
+        </p:nvSpPr>
+        <p:spPr>
+          <a:xfrm>
+            <a:off x="795528" y="2560320"/>
+            <a:ext cx="4824832" cy="868680"/>
+          </a:xfrm>
+          <a:prstGeom prst="rect">
+            <a:avLst/>
+          </a:prstGeom>
+          <a:noFill/>
+          <a:ln/>
+        </p:spPr>
+        <p:txBody>
+          <a:bodyPr wrap="square" lIns="0" tIns="0" rIns="0" bIns="0" rtlCol="0" anchor="ctr"/>
           <a:lstStyle/>
           <a:p>
             <a:pPr indent="0" marL="0">
               <a:lnSpc>
-                <a:spcPct val="105000"/>
+                <a:spcPct val="115000"/>
               </a:lnSpc>
               <a:buNone/>
             </a:pPr>
             <a:r>
-              <a:rPr lang="en-US" sz="1150" dirty="0">
-                <a:solidFill>
-                  <a:srgbClr val="1E2A3A"/>
+              <a:rPr lang="en-US" sz="1200" dirty="0">
+                <a:solidFill>
+                  <a:srgbClr val="6B7280"/>
                 </a:solidFill>
                 <a:latin typeface="Calibri" pitchFamily="34" charset="0"/>
                 <a:ea typeface="Calibri" pitchFamily="34" charset="-122"/>
                 <a:cs typeface="Calibri" pitchFamily="34" charset="-120"/>
               </a:rPr>
-              <a:t>Structured, longer AI Summary format (up from a one-line blurb)</a:t>
-            </a:r>
-            <a:endParaRPr lang="en-US" sz="1150" dirty="0"/>
-          </a:p>
-        </p:txBody>
+              <a:t>Every AI-generated insight will link back to the specific saved paper(s) it drew from, so output stays grounded in citable sources rather than a bare claim.</a:t>
+            </a:r>
+            <a:endParaRPr lang="en-US" sz="1200" dirty="0"/>
+          </a:p>
+        </p:txBody>
+      </p:sp>
+      <p:sp>
+        <p:nvSpPr>
+          <p:cNvPr id="9" name="Shape 6"/>
+          <p:cNvSpPr/>
+          <p:nvPr/>
+        </p:nvSpPr>
+        <p:spPr>
+          <a:xfrm>
+            <a:off x="6278728" y="1600200"/>
+            <a:ext cx="5410048" cy="2057400"/>
+          </a:xfrm>
+          <a:prstGeom prst="roundRect">
+            <a:avLst>
+              <a:gd name="adj" fmla="val 4000"/>
+            </a:avLst>
+          </a:prstGeom>
+          <a:solidFill>
+            <a:srgbClr val="FFFFFF"/>
+          </a:solidFill>
+          <a:ln w="12700">
+            <a:solidFill>
+              <a:srgbClr val="E5E7EB"/>
+            </a:solidFill>
+            <a:prstDash val="solid"/>
+          </a:ln>
+          <a:effectLst>
+            <a:outerShdw sx="100000" sy="100000" kx="0" ky="0" algn="bl" rotWithShape="0" blurRad="101600" dist="38100" dir="5400000">
+              <a:srgbClr val="1E2A3A">
+                <a:alpha val="12000"/>
+              </a:srgbClr>
+            </a:outerShdw>
+          </a:effectLst>
+        </p:spPr>
+      </p:sp>
+      <p:sp>
+        <p:nvSpPr>
+          <p:cNvPr id="10" name="Shape 7"/>
+          <p:cNvSpPr/>
+          <p:nvPr/>
+        </p:nvSpPr>
+        <p:spPr>
+          <a:xfrm>
+            <a:off x="6571336" y="1892808"/>
+            <a:ext cx="566928" cy="566928"/>
+          </a:xfrm>
+          <a:prstGeom prst="ellipse">
+            <a:avLst/>
+          </a:prstGeom>
+          <a:solidFill>
+            <a:srgbClr val="EFF6FF"/>
+          </a:solidFill>
+          <a:ln/>
+        </p:spPr>
       </p:sp>
       <p:pic>
         <p:nvPicPr>
-          <p:cNvPr id="16" name="Image 1" descr="/tmp/claude-0/-home-claude/8aa44312-0fe2-5592-9e58-f7573fdf65a9/scratchpad/pptx_work/icons/check-green.png">    </p:cNvPr>
+          <p:cNvPr id="11" name="Image 1" descr="/tmp/claude-0/-home-claude/8aa44312-0fe2-5592-9e58-f7573fdf65a9/scratchpad/pptx_work/icons/message.png">    </p:cNvPr>
           <p:cNvPicPr>
             <a:picLocks noChangeAspect="1"/>
           </p:cNvPicPr>
@@ -3782,8 +3590,8 @@
         </p:blipFill>
         <p:spPr>
           <a:xfrm>
-            <a:off x="6255868" y="3794760"/>
-            <a:ext cx="201168" cy="201168"/>
+            <a:off x="6718737" y="2040209"/>
+            <a:ext cx="272125" cy="272125"/>
           </a:xfrm>
           <a:prstGeom prst="rect">
             <a:avLst/>
@@ -3792,49 +3600,142 @@
       </p:pic>
       <p:sp>
         <p:nvSpPr>
-          <p:cNvPr id="17" name="Text 13"/>
-          <p:cNvSpPr txBox="1"/>
-          <p:nvPr/>
-        </p:nvSpPr>
-        <p:spPr>
-          <a:xfrm>
-            <a:off x="6566764" y="3712464"/>
-            <a:ext cx="5122012" cy="502920"/>
-          </a:xfrm>
-          <a:prstGeom prst="rect">
-            <a:avLst/>
-          </a:prstGeom>
-          <a:noFill/>
-          <a:ln/>
-        </p:spPr>
-        <p:txBody>
-          <a:bodyPr wrap="square" lIns="0" tIns="0" rIns="0" bIns="0" rtlCol="0" anchor="t"/>
+          <p:cNvPr id="12" name="Text 8"/>
+          <p:cNvSpPr txBox="1"/>
+          <p:nvPr/>
+        </p:nvSpPr>
+        <p:spPr>
+          <a:xfrm>
+            <a:off x="7330288" y="1892808"/>
+            <a:ext cx="4084168" cy="365760"/>
+          </a:xfrm>
+          <a:prstGeom prst="rect">
+            <a:avLst/>
+          </a:prstGeom>
+          <a:noFill/>
+          <a:ln/>
+        </p:spPr>
+        <p:txBody>
+          <a:bodyPr wrap="square" lIns="0" tIns="0" rIns="0" bIns="0" rtlCol="0" anchor="ctr"/>
+          <a:lstStyle/>
+          <a:p>
+            <a:pPr indent="0" marL="0">
+              <a:buNone/>
+            </a:pPr>
+            <a:r>
+              <a:rPr lang="en-US" sz="1650" b="1" dirty="0">
+                <a:solidFill>
+                  <a:srgbClr val="0F172A"/>
+                </a:solidFill>
+                <a:latin typeface="Cambria" pitchFamily="34" charset="0"/>
+                <a:ea typeface="Cambria" pitchFamily="34" charset="-122"/>
+                <a:cs typeface="Cambria" pitchFamily="34" charset="-120"/>
+              </a:rPr>
+              <a:t>Ask Your Literature</a:t>
+            </a:r>
+            <a:endParaRPr lang="en-US" sz="1650" dirty="0"/>
+          </a:p>
+        </p:txBody>
+      </p:sp>
+      <p:sp>
+        <p:nvSpPr>
+          <p:cNvPr id="13" name="Text 9"/>
+          <p:cNvSpPr txBox="1"/>
+          <p:nvPr/>
+        </p:nvSpPr>
+        <p:spPr>
+          <a:xfrm>
+            <a:off x="6571336" y="2560320"/>
+            <a:ext cx="4824832" cy="868680"/>
+          </a:xfrm>
+          <a:prstGeom prst="rect">
+            <a:avLst/>
+          </a:prstGeom>
+          <a:noFill/>
+          <a:ln/>
+        </p:spPr>
+        <p:txBody>
+          <a:bodyPr wrap="square" lIns="0" tIns="0" rIns="0" bIns="0" rtlCol="0" anchor="ctr"/>
           <a:lstStyle/>
           <a:p>
             <a:pPr indent="0" marL="0">
               <a:lnSpc>
-                <a:spcPct val="105000"/>
+                <a:spcPct val="115000"/>
               </a:lnSpc>
               <a:buNone/>
             </a:pPr>
             <a:r>
-              <a:rPr lang="en-US" sz="1150" dirty="0">
-                <a:solidFill>
-                  <a:srgbClr val="1E2A3A"/>
+              <a:rPr lang="en-US" sz="1200" dirty="0">
+                <a:solidFill>
+                  <a:srgbClr val="6B7280"/>
                 </a:solidFill>
                 <a:latin typeface="Calibri" pitchFamily="34" charset="0"/>
                 <a:ea typeface="Calibri" pitchFamily="34" charset="-122"/>
                 <a:cs typeface="Calibri" pitchFamily="34" charset="-120"/>
               </a:rPr>
-              <a:t>Relevance Analysis grounded in each project's own research question</a:t>
-            </a:r>
-            <a:endParaRPr lang="en-US" sz="1150" dirty="0"/>
-          </a:p>
-        </p:txBody>
+              <a:t>A question-answering feature grounded in, and cited to, the papers you've saved - retrieval scoped only to your own library, never the open web.</a:t>
+            </a:r>
+            <a:endParaRPr lang="en-US" sz="1200" dirty="0"/>
+          </a:p>
+        </p:txBody>
+      </p:sp>
+      <p:sp>
+        <p:nvSpPr>
+          <p:cNvPr id="14" name="Shape 10"/>
+          <p:cNvSpPr/>
+          <p:nvPr/>
+        </p:nvSpPr>
+        <p:spPr>
+          <a:xfrm>
+            <a:off x="502920" y="4023360"/>
+            <a:ext cx="5410048" cy="2057400"/>
+          </a:xfrm>
+          <a:prstGeom prst="roundRect">
+            <a:avLst>
+              <a:gd name="adj" fmla="val 4000"/>
+            </a:avLst>
+          </a:prstGeom>
+          <a:solidFill>
+            <a:srgbClr val="FFFFFF"/>
+          </a:solidFill>
+          <a:ln w="12700">
+            <a:solidFill>
+              <a:srgbClr val="E5E7EB"/>
+            </a:solidFill>
+            <a:prstDash val="solid"/>
+          </a:ln>
+          <a:effectLst>
+            <a:outerShdw sx="100000" sy="100000" kx="0" ky="0" algn="bl" rotWithShape="0" blurRad="101600" dist="38100" dir="5400000">
+              <a:srgbClr val="1E2A3A">
+                <a:alpha val="12000"/>
+              </a:srgbClr>
+            </a:outerShdw>
+          </a:effectLst>
+        </p:spPr>
+      </p:sp>
+      <p:sp>
+        <p:nvSpPr>
+          <p:cNvPr id="15" name="Shape 11"/>
+          <p:cNvSpPr/>
+          <p:nvPr/>
+        </p:nvSpPr>
+        <p:spPr>
+          <a:xfrm>
+            <a:off x="795528" y="4315968"/>
+            <a:ext cx="566928" cy="566928"/>
+          </a:xfrm>
+          <a:prstGeom prst="ellipse">
+            <a:avLst/>
+          </a:prstGeom>
+          <a:solidFill>
+            <a:srgbClr val="EFF6FF"/>
+          </a:solidFill>
+          <a:ln/>
+        </p:spPr>
       </p:sp>
       <p:pic>
         <p:nvPicPr>
-          <p:cNvPr id="18" name="Image 2" descr="/tmp/claude-0/-home-claude/8aa44312-0fe2-5592-9e58-f7573fdf65a9/scratchpad/pptx_work/icons/check-green.png">    </p:cNvPr>
+          <p:cNvPr id="16" name="Image 2" descr="/tmp/claude-0/-home-claude/8aa44312-0fe2-5592-9e58-f7573fdf65a9/scratchpad/pptx_work/icons/columns.png">    </p:cNvPr>
           <p:cNvPicPr>
             <a:picLocks noChangeAspect="1"/>
           </p:cNvPicPr>
@@ -3848,8 +3749,8 @@
         </p:blipFill>
         <p:spPr>
           <a:xfrm>
-            <a:off x="502920" y="4526280"/>
-            <a:ext cx="201168" cy="201168"/>
+            <a:off x="942929" y="4463369"/>
+            <a:ext cx="272125" cy="272125"/>
           </a:xfrm>
           <a:prstGeom prst="rect">
             <a:avLst/>
@@ -3858,49 +3759,203 @@
       </p:pic>
       <p:sp>
         <p:nvSpPr>
+          <p:cNvPr id="17" name="Text 12"/>
+          <p:cNvSpPr txBox="1"/>
+          <p:nvPr/>
+        </p:nvSpPr>
+        <p:spPr>
+          <a:xfrm>
+            <a:off x="1554480" y="4315968"/>
+            <a:ext cx="2849728" cy="365760"/>
+          </a:xfrm>
+          <a:prstGeom prst="rect">
+            <a:avLst/>
+          </a:prstGeom>
+          <a:noFill/>
+          <a:ln/>
+        </p:spPr>
+        <p:txBody>
+          <a:bodyPr wrap="square" lIns="0" tIns="0" rIns="0" bIns="0" rtlCol="0" anchor="ctr"/>
+          <a:lstStyle/>
+          <a:p>
+            <a:pPr indent="0" marL="0">
+              <a:buNone/>
+            </a:pPr>
+            <a:r>
+              <a:rPr lang="en-US" sz="1650" b="1" dirty="0">
+                <a:solidFill>
+                  <a:srgbClr val="0F172A"/>
+                </a:solidFill>
+                <a:latin typeface="Cambria" pitchFamily="34" charset="0"/>
+                <a:ea typeface="Cambria" pitchFamily="34" charset="-122"/>
+                <a:cs typeface="Cambria" pitchFamily="34" charset="-120"/>
+              </a:rPr>
+              <a:t>Paper Comparison</a:t>
+            </a:r>
+            <a:endParaRPr lang="en-US" sz="1650" dirty="0"/>
+          </a:p>
+        </p:txBody>
+      </p:sp>
+      <p:sp>
+        <p:nvSpPr>
+          <p:cNvPr id="18" name="Shape 13"/>
+          <p:cNvSpPr/>
+          <p:nvPr/>
+        </p:nvSpPr>
+        <p:spPr>
+          <a:xfrm>
+            <a:off x="4486504" y="4325112"/>
+            <a:ext cx="1170432" cy="310896"/>
+          </a:xfrm>
+          <a:prstGeom prst="roundRect">
+            <a:avLst>
+              <a:gd name="adj" fmla="val 50000"/>
+            </a:avLst>
+          </a:prstGeom>
+          <a:solidFill>
+            <a:srgbClr val="ECFDF5"/>
+          </a:solidFill>
+          <a:ln/>
+        </p:spPr>
+      </p:sp>
+      <p:sp>
+        <p:nvSpPr>
           <p:cNvPr id="19" name="Text 14"/>
           <p:cNvSpPr txBox="1"/>
           <p:nvPr/>
         </p:nvSpPr>
         <p:spPr>
           <a:xfrm>
-            <a:off x="813816" y="4443984"/>
-            <a:ext cx="5122012" cy="502920"/>
-          </a:xfrm>
-          <a:prstGeom prst="rect">
-            <a:avLst/>
-          </a:prstGeom>
-          <a:noFill/>
-          <a:ln/>
-        </p:spPr>
-        <p:txBody>
-          <a:bodyPr wrap="square" lIns="0" tIns="0" rIns="0" bIns="0" rtlCol="0" anchor="t"/>
-          <a:lstStyle/>
-          <a:p>
-            <a:pPr indent="0" marL="0">
-              <a:lnSpc>
-                <a:spcPct val="105000"/>
-              </a:lnSpc>
-              <a:buNone/>
-            </a:pPr>
-            <a:r>
-              <a:rPr lang="en-US" sz="1150" dirty="0">
-                <a:solidFill>
-                  <a:srgbClr val="1E2A3A"/>
+            <a:off x="4486504" y="4325112"/>
+            <a:ext cx="1170432" cy="310896"/>
+          </a:xfrm>
+          <a:prstGeom prst="rect">
+            <a:avLst/>
+          </a:prstGeom>
+          <a:noFill/>
+          <a:ln/>
+        </p:spPr>
+        <p:txBody>
+          <a:bodyPr wrap="square" lIns="0" tIns="0" rIns="0" bIns="0" rtlCol="0" anchor="ctr"/>
+          <a:lstStyle/>
+          <a:p>
+            <a:pPr algn="ctr" indent="0" marL="0">
+              <a:buNone/>
+            </a:pPr>
+            <a:r>
+              <a:rPr lang="en-US" sz="950" b="1" dirty="0">
+                <a:solidFill>
+                  <a:srgbClr val="0F5132"/>
                 </a:solidFill>
                 <a:latin typeface="Calibri" pitchFamily="34" charset="0"/>
                 <a:ea typeface="Calibri" pitchFamily="34" charset="-122"/>
                 <a:cs typeface="Calibri" pitchFamily="34" charset="-120"/>
               </a:rPr>
-              <a:t>New "AI Paper Analysis" hub page across every saved paper</a:t>
-            </a:r>
-            <a:endParaRPr lang="en-US" sz="1150" dirty="0"/>
-          </a:p>
-        </p:txBody>
+              <a:t>Started Early</a:t>
+            </a:r>
+            <a:endParaRPr lang="en-US" sz="950" dirty="0"/>
+          </a:p>
+        </p:txBody>
+      </p:sp>
+      <p:sp>
+        <p:nvSpPr>
+          <p:cNvPr id="20" name="Text 15"/>
+          <p:cNvSpPr txBox="1"/>
+          <p:nvPr/>
+        </p:nvSpPr>
+        <p:spPr>
+          <a:xfrm>
+            <a:off x="795528" y="4983480"/>
+            <a:ext cx="4824832" cy="868680"/>
+          </a:xfrm>
+          <a:prstGeom prst="rect">
+            <a:avLst/>
+          </a:prstGeom>
+          <a:noFill/>
+          <a:ln/>
+        </p:spPr>
+        <p:txBody>
+          <a:bodyPr wrap="square" lIns="0" tIns="0" rIns="0" bIns="0" rtlCol="0" anchor="ctr"/>
+          <a:lstStyle/>
+          <a:p>
+            <a:pPr indent="0" marL="0">
+              <a:lnSpc>
+                <a:spcPct val="115000"/>
+              </a:lnSpc>
+              <a:buNone/>
+            </a:pPr>
+            <a:r>
+              <a:rPr lang="en-US" sz="1200" dirty="0">
+                <a:solidFill>
+                  <a:srgbClr val="6B7280"/>
+                </a:solidFill>
+                <a:latin typeface="Calibri" pitchFamily="34" charset="0"/>
+                <a:ea typeface="Calibri" pitchFamily="34" charset="-122"/>
+                <a:cs typeface="Calibri" pitchFamily="34" charset="-120"/>
+              </a:rPr>
+              <a:t>Structured, side-by-side comparison across multiple saved papers.</a:t>
+            </a:r>
+            <a:endParaRPr lang="en-US" sz="1200" dirty="0"/>
+          </a:p>
+        </p:txBody>
+      </p:sp>
+      <p:sp>
+        <p:nvSpPr>
+          <p:cNvPr id="21" name="Shape 16"/>
+          <p:cNvSpPr/>
+          <p:nvPr/>
+        </p:nvSpPr>
+        <p:spPr>
+          <a:xfrm>
+            <a:off x="6278728" y="4023360"/>
+            <a:ext cx="5410048" cy="2057400"/>
+          </a:xfrm>
+          <a:prstGeom prst="roundRect">
+            <a:avLst>
+              <a:gd name="adj" fmla="val 4000"/>
+            </a:avLst>
+          </a:prstGeom>
+          <a:solidFill>
+            <a:srgbClr val="FFFFFF"/>
+          </a:solidFill>
+          <a:ln w="12700">
+            <a:solidFill>
+              <a:srgbClr val="E5E7EB"/>
+            </a:solidFill>
+            <a:prstDash val="solid"/>
+          </a:ln>
+          <a:effectLst>
+            <a:outerShdw sx="100000" sy="100000" kx="0" ky="0" algn="bl" rotWithShape="0" blurRad="101600" dist="38100" dir="5400000">
+              <a:srgbClr val="1E2A3A">
+                <a:alpha val="12000"/>
+              </a:srgbClr>
+            </a:outerShdw>
+          </a:effectLst>
+        </p:spPr>
+      </p:sp>
+      <p:sp>
+        <p:nvSpPr>
+          <p:cNvPr id="22" name="Shape 17"/>
+          <p:cNvSpPr/>
+          <p:nvPr/>
+        </p:nvSpPr>
+        <p:spPr>
+          <a:xfrm>
+            <a:off x="6571336" y="4315968"/>
+            <a:ext cx="566928" cy="566928"/>
+          </a:xfrm>
+          <a:prstGeom prst="ellipse">
+            <a:avLst/>
+          </a:prstGeom>
+          <a:solidFill>
+            <a:srgbClr val="EFF6FF"/>
+          </a:solidFill>
+          <a:ln/>
+        </p:spPr>
       </p:sp>
       <p:pic>
         <p:nvPicPr>
-          <p:cNvPr id="20" name="Image 3" descr="/tmp/claude-0/-home-claude/8aa44312-0fe2-5592-9e58-f7573fdf65a9/scratchpad/pptx_work/icons/check-green.png">    </p:cNvPr>
+          <p:cNvPr id="23" name="Image 3" descr="/tmp/claude-0/-home-claude/8aa44312-0fe2-5592-9e58-f7573fdf65a9/scratchpad/pptx_work/icons/brain.png">    </p:cNvPr>
           <p:cNvPicPr>
             <a:picLocks noChangeAspect="1"/>
           </p:cNvPicPr>
@@ -3914,8 +3969,8 @@
         </p:blipFill>
         <p:spPr>
           <a:xfrm>
-            <a:off x="6255868" y="4526280"/>
-            <a:ext cx="201168" cy="201168"/>
+            <a:off x="6718737" y="4463369"/>
+            <a:ext cx="272125" cy="272125"/>
           </a:xfrm>
           <a:prstGeom prst="rect">
             <a:avLst/>
@@ -3924,211 +3979,118 @@
       </p:pic>
       <p:sp>
         <p:nvSpPr>
-          <p:cNvPr id="21" name="Text 15"/>
-          <p:cNvSpPr txBox="1"/>
-          <p:nvPr/>
-        </p:nvSpPr>
-        <p:spPr>
-          <a:xfrm>
-            <a:off x="6566764" y="4443984"/>
-            <a:ext cx="5122012" cy="502920"/>
-          </a:xfrm>
-          <a:prstGeom prst="rect">
-            <a:avLst/>
-          </a:prstGeom>
-          <a:noFill/>
-          <a:ln/>
-        </p:spPr>
-        <p:txBody>
-          <a:bodyPr wrap="square" lIns="0" tIns="0" rIns="0" bIns="0" rtlCol="0" anchor="t"/>
+          <p:cNvPr id="24" name="Text 18"/>
+          <p:cNvSpPr txBox="1"/>
+          <p:nvPr/>
+        </p:nvSpPr>
+        <p:spPr>
+          <a:xfrm>
+            <a:off x="7330288" y="4315968"/>
+            <a:ext cx="4084168" cy="365760"/>
+          </a:xfrm>
+          <a:prstGeom prst="rect">
+            <a:avLst/>
+          </a:prstGeom>
+          <a:noFill/>
+          <a:ln/>
+        </p:spPr>
+        <p:txBody>
+          <a:bodyPr wrap="square" lIns="0" tIns="0" rIns="0" bIns="0" rtlCol="0" anchor="ctr"/>
+          <a:lstStyle/>
+          <a:p>
+            <a:pPr indent="0" marL="0">
+              <a:buNone/>
+            </a:pPr>
+            <a:r>
+              <a:rPr lang="en-US" sz="1650" b="1" dirty="0">
+                <a:solidFill>
+                  <a:srgbClr val="0F172A"/>
+                </a:solidFill>
+                <a:latin typeface="Cambria" pitchFamily="34" charset="0"/>
+                <a:ea typeface="Cambria" pitchFamily="34" charset="-122"/>
+                <a:cs typeface="Cambria" pitchFamily="34" charset="-120"/>
+              </a:rPr>
+              <a:t>A Minimal OpenAI Agent</a:t>
+            </a:r>
+            <a:endParaRPr lang="en-US" sz="1650" dirty="0"/>
+          </a:p>
+        </p:txBody>
+      </p:sp>
+      <p:sp>
+        <p:nvSpPr>
+          <p:cNvPr id="25" name="Text 19"/>
+          <p:cNvSpPr txBox="1"/>
+          <p:nvPr/>
+        </p:nvSpPr>
+        <p:spPr>
+          <a:xfrm>
+            <a:off x="6571336" y="4983480"/>
+            <a:ext cx="4824832" cy="868680"/>
+          </a:xfrm>
+          <a:prstGeom prst="rect">
+            <a:avLst/>
+          </a:prstGeom>
+          <a:noFill/>
+          <a:ln/>
+        </p:spPr>
+        <p:txBody>
+          <a:bodyPr wrap="square" lIns="0" tIns="0" rIns="0" bIns="0" rtlCol="0" anchor="ctr"/>
           <a:lstStyle/>
           <a:p>
             <a:pPr indent="0" marL="0">
               <a:lnSpc>
-                <a:spcPct val="105000"/>
+                <a:spcPct val="115000"/>
               </a:lnSpc>
               <a:buNone/>
             </a:pPr>
             <a:r>
-              <a:rPr lang="en-US" sz="1150" dirty="0">
-                <a:solidFill>
-                  <a:srgbClr val="1E2A3A"/>
+              <a:rPr lang="en-US" sz="1200" dirty="0">
+                <a:solidFill>
+                  <a:srgbClr val="6B7280"/>
                 </a:solidFill>
                 <a:latin typeface="Calibri" pitchFamily="34" charset="0"/>
                 <a:ea typeface="Calibri" pitchFamily="34" charset="-122"/>
                 <a:cs typeface="Calibri" pitchFamily="34" charset="-120"/>
               </a:rPr>
-              <a:t>Multi-note system: unlimited titled notes, add / edit / delete</a:t>
-            </a:r>
-            <a:endParaRPr lang="en-US" sz="1150" dirty="0"/>
-          </a:p>
-        </p:txBody>
-      </p:sp>
-      <p:pic>
-        <p:nvPicPr>
-          <p:cNvPr id="22" name="Image 4" descr="/tmp/claude-0/-home-claude/8aa44312-0fe2-5592-9e58-f7573fdf65a9/scratchpad/pptx_work/icons/check-green.png">    </p:cNvPr>
-          <p:cNvPicPr>
-            <a:picLocks noChangeAspect="1"/>
-          </p:cNvPicPr>
-          <p:nvPr/>
-        </p:nvPicPr>
-        <p:blipFill>
-          <a:blip r:embed="rId5"/>
-          <a:stretch>
-            <a:fillRect/>
-          </a:stretch>
-        </p:blipFill>
-        <p:spPr>
-          <a:xfrm>
-            <a:off x="502920" y="5257800"/>
-            <a:ext cx="201168" cy="201168"/>
-          </a:xfrm>
-          <a:prstGeom prst="rect">
-            <a:avLst/>
-          </a:prstGeom>
-        </p:spPr>
-      </p:pic>
-      <p:sp>
-        <p:nvSpPr>
-          <p:cNvPr id="23" name="Text 16"/>
-          <p:cNvSpPr txBox="1"/>
-          <p:nvPr/>
-        </p:nvSpPr>
-        <p:spPr>
-          <a:xfrm>
-            <a:off x="813816" y="5175504"/>
-            <a:ext cx="5122012" cy="502920"/>
-          </a:xfrm>
-          <a:prstGeom prst="rect">
-            <a:avLst/>
-          </a:prstGeom>
-          <a:noFill/>
-          <a:ln/>
-        </p:spPr>
-        <p:txBody>
-          <a:bodyPr wrap="square" lIns="0" tIns="0" rIns="0" bIns="0" rtlCol="0" anchor="t"/>
+              <a:t>The project's core agentic AI deliverable: a small, tool-using agent that plans and carries out a short multi-step task over your saved literature.</a:t>
+            </a:r>
+            <a:endParaRPr lang="en-US" sz="1200" dirty="0"/>
+          </a:p>
+        </p:txBody>
+      </p:sp>
+      <p:sp>
+        <p:nvSpPr>
+          <p:cNvPr id="26" name="Text 20"/>
+          <p:cNvSpPr txBox="1"/>
+          <p:nvPr/>
+        </p:nvSpPr>
+        <p:spPr>
+          <a:xfrm>
+            <a:off x="502920" y="6473952"/>
+            <a:ext cx="4572000" cy="274320"/>
+          </a:xfrm>
+          <a:prstGeom prst="rect">
+            <a:avLst/>
+          </a:prstGeom>
+          <a:noFill/>
+          <a:ln/>
+        </p:spPr>
+        <p:txBody>
+          <a:bodyPr wrap="square" lIns="0" tIns="0" rIns="0" bIns="0" rtlCol="0" anchor="ctr"/>
           <a:lstStyle/>
           <a:p>
             <a:pPr indent="0" marL="0">
-              <a:lnSpc>
-                <a:spcPct val="105000"/>
-              </a:lnSpc>
-              <a:buNone/>
-            </a:pPr>
-            <a:r>
-              <a:rPr lang="en-US" sz="1150" dirty="0">
-                <a:solidFill>
-                  <a:srgbClr val="1E2A3A"/>
+              <a:buNone/>
+            </a:pPr>
+            <a:r>
+              <a:rPr lang="en-US" sz="900" dirty="0">
+                <a:solidFill>
+                  <a:srgbClr val="6B7280"/>
                 </a:solidFill>
                 <a:latin typeface="Calibri" pitchFamily="34" charset="0"/>
                 <a:ea typeface="Calibri" pitchFamily="34" charset="-122"/>
                 <a:cs typeface="Calibri" pitchFamily="34" charset="-120"/>
               </a:rPr>
-              <a:t>Legacy single-note field migrated to the new system automatically</a:t>
-            </a:r>
-            <a:endParaRPr lang="en-US" sz="1150" dirty="0"/>
-          </a:p>
-        </p:txBody>
-      </p:sp>
-      <p:pic>
-        <p:nvPicPr>
-          <p:cNvPr id="24" name="Image 5" descr="/tmp/claude-0/-home-claude/8aa44312-0fe2-5592-9e58-f7573fdf65a9/scratchpad/pptx_work/icons/check-green.png">    </p:cNvPr>
-          <p:cNvPicPr>
-            <a:picLocks noChangeAspect="1"/>
-          </p:cNvPicPr>
-          <p:nvPr/>
-        </p:nvPicPr>
-        <p:blipFill>
-          <a:blip r:embed="rId6"/>
-          <a:stretch>
-            <a:fillRect/>
-          </a:stretch>
-        </p:blipFill>
-        <p:spPr>
-          <a:xfrm>
-            <a:off x="6255868" y="5257800"/>
-            <a:ext cx="201168" cy="201168"/>
-          </a:xfrm>
-          <a:prstGeom prst="rect">
-            <a:avLst/>
-          </a:prstGeom>
-        </p:spPr>
-      </p:pic>
-      <p:sp>
-        <p:nvSpPr>
-          <p:cNvPr id="25" name="Text 17"/>
-          <p:cNvSpPr txBox="1"/>
-          <p:nvPr/>
-        </p:nvSpPr>
-        <p:spPr>
-          <a:xfrm>
-            <a:off x="6566764" y="5175504"/>
-            <a:ext cx="5122012" cy="502920"/>
-          </a:xfrm>
-          <a:prstGeom prst="rect">
-            <a:avLst/>
-          </a:prstGeom>
-          <a:noFill/>
-          <a:ln/>
-        </p:spPr>
-        <p:txBody>
-          <a:bodyPr wrap="square" lIns="0" tIns="0" rIns="0" bIns="0" rtlCol="0" anchor="t"/>
-          <a:lstStyle/>
-          <a:p>
-            <a:pPr indent="0" marL="0">
-              <a:lnSpc>
-                <a:spcPct val="105000"/>
-              </a:lnSpc>
-              <a:buNone/>
-            </a:pPr>
-            <a:r>
-              <a:rPr lang="en-US" sz="1150" dirty="0">
-                <a:solidFill>
-                  <a:srgbClr val="1E2A3A"/>
-                </a:solidFill>
-                <a:latin typeface="Calibri" pitchFamily="34" charset="0"/>
-                <a:ea typeface="Calibri" pitchFamily="34" charset="-122"/>
-                <a:cs typeface="Calibri" pitchFamily="34" charset="-120"/>
-              </a:rPr>
-              <a:t>All four Sprint 3 roadmap items delivered end-to-end</a:t>
-            </a:r>
-            <a:endParaRPr lang="en-US" sz="1150" dirty="0"/>
-          </a:p>
-        </p:txBody>
-      </p:sp>
-      <p:sp>
-        <p:nvSpPr>
-          <p:cNvPr id="26" name="Text 18"/>
-          <p:cNvSpPr txBox="1"/>
-          <p:nvPr/>
-        </p:nvSpPr>
-        <p:spPr>
-          <a:xfrm>
-            <a:off x="502920" y="6473952"/>
-            <a:ext cx="4572000" cy="274320"/>
-          </a:xfrm>
-          <a:prstGeom prst="rect">
-            <a:avLst/>
-          </a:prstGeom>
-          <a:noFill/>
-          <a:ln/>
-        </p:spPr>
-        <p:txBody>
-          <a:bodyPr wrap="square" lIns="0" tIns="0" rIns="0" bIns="0" rtlCol="0" anchor="ctr"/>
-          <a:lstStyle/>
-          <a:p>
-            <a:pPr indent="0" marL="0">
-              <a:buNone/>
-            </a:pPr>
-            <a:r>
-              <a:rPr lang="en-US" sz="900" dirty="0">
-                <a:solidFill>
-                  <a:srgbClr val="6B7280"/>
-                </a:solidFill>
-                <a:latin typeface="Calibri" pitchFamily="34" charset="0"/>
-                <a:ea typeface="Calibri" pitchFamily="34" charset="-122"/>
-                <a:cs typeface="Calibri" pitchFamily="34" charset="-120"/>
-              </a:rPr>
               <a:t>ResearchLens AI  ·  Sprint 3 Update</a:t>
             </a:r>
             <a:endParaRPr lang="en-US" sz="900" dirty="0"/>
@@ -4137,7 +4099,7 @@
       </p:sp>
       <p:sp>
         <p:nvSpPr>
-          <p:cNvPr id="27" name="Text 19"/>
+          <p:cNvPr id="27" name="Text 21"/>
           <p:cNvSpPr txBox="1"/>
           <p:nvPr/>
         </p:nvSpPr>

</xml_diff>